<commit_message>
Add audit review for "A Skeptic's Guide to Surviving AI in Education" and sync talks script improvements
- Created a new audit review file for the skeptic-education talk, detailing verdicts, blocking issues, consistency findings, correctness findings, direction alignment, voice, cruft, and proposed edits.
- Updated the sync-talks script to merge previous exports with fresh records, ensuring no talks are dropped from shared indexes.
- Enhanced the generation of the exports.json file to include merged data from prior exports.
</commit_message>
<xml_diff>
--- a/artifacts/speaking-portfolio-expanded/decks/retrieval-15min-handout.pptx
+++ b/artifacts/speaking-portfolio-expanded/decks/retrieval-15min-handout.pptx
@@ -328,7 +328,7 @@
                 <a:ea typeface="Arial"/>
                 <a:cs typeface="Arial"/>
               </a:rPr>
-              <a:t xml:space="preserve">Your Eval Suite Has a Grandfather</a:t>
+              <a:t xml:space="preserve">Three Search Methods in a Fundable Trenchcoat</a:t>
             </a:r>
             <a:endParaRPr lang="en-US" sz="1200"/>
           </a:p>
@@ -809,7 +809,7 @@
                 <a:ea typeface="Arial"/>
                 <a:cs typeface="Arial"/>
               </a:rPr>
-              <a:t xml:space="preserve">Your Eval Suite Has a Grandfather</a:t>
+              <a:t xml:space="preserve">Three Search Methods in a Fundable Trenchcoat</a:t>
             </a:r>
             <a:endParaRPr lang="en-US" sz="1200"/>
           </a:p>
@@ -1290,7 +1290,7 @@
                 <a:ea typeface="Arial"/>
                 <a:cs typeface="Arial"/>
               </a:rPr>
-              <a:t xml:space="preserve">Your Eval Suite Has a Grandfather</a:t>
+              <a:t xml:space="preserve">Three Search Methods in a Fundable Trenchcoat</a:t>
             </a:r>
             <a:endParaRPr lang="en-US" sz="1200"/>
           </a:p>
@@ -1909,7 +1909,7 @@
                 <a:ea typeface="Arial"/>
                 <a:cs typeface="Arial"/>
               </a:rPr>
-              <a:t xml:space="preserve">Your Eval Suite Has a Grandfather</a:t>
+              <a:t xml:space="preserve">Three Search Methods in a Fundable Trenchcoat</a:t>
             </a:r>
             <a:endParaRPr lang="en-US" sz="1200"/>
           </a:p>
@@ -2436,7 +2436,7 @@
                 <a:ea typeface="Arial"/>
                 <a:cs typeface="Arial"/>
               </a:rPr>
-              <a:t xml:space="preserve">Your Eval Suite Has a Grandfather</a:t>
+              <a:t xml:space="preserve">Three Search Methods in a Fundable Trenchcoat</a:t>
             </a:r>
             <a:endParaRPr lang="en-US" sz="1200"/>
           </a:p>
@@ -3055,7 +3055,7 @@
                 <a:ea typeface="Arial"/>
                 <a:cs typeface="Arial"/>
               </a:rPr>
-              <a:t xml:space="preserve">Your Eval Suite Has a Grandfather</a:t>
+              <a:t xml:space="preserve">Three Search Methods in a Fundable Trenchcoat</a:t>
             </a:r>
             <a:endParaRPr lang="en-US" sz="1200"/>
           </a:p>
@@ -3582,7 +3582,7 @@
                 <a:ea typeface="Arial"/>
                 <a:cs typeface="Arial"/>
               </a:rPr>
-              <a:t xml:space="preserve">Your Eval Suite Has a Grandfather</a:t>
+              <a:t xml:space="preserve">Three Search Methods in a Fundable Trenchcoat</a:t>
             </a:r>
             <a:endParaRPr lang="en-US" sz="1200"/>
           </a:p>
@@ -4063,7 +4063,7 @@
                 <a:ea typeface="Arial"/>
                 <a:cs typeface="Arial"/>
               </a:rPr>
-              <a:t xml:space="preserve">Your Eval Suite Has a Grandfather</a:t>
+              <a:t xml:space="preserve">Three Search Methods in a Fundable Trenchcoat</a:t>
             </a:r>
             <a:endParaRPr lang="en-US" sz="1200"/>
           </a:p>
@@ -4155,7 +4155,7 @@
                 <a:ea typeface="Arial"/>
                 <a:cs typeface="Arial"/>
               </a:rPr>
-              <a:t xml:space="preserve">Your eval suite has a grandfather.</a:t>
+              <a:t xml:space="preserve">Three search methods in a fundable trenchcoat.</a:t>
             </a:r>
             <a:endParaRPr lang="en-US" sz="1200"/>
           </a:p>
@@ -4664,7 +4664,30 @@
                 <a:ea typeface="Arial"/>
                 <a:cs typeface="Arial"/>
               </a:rPr>
-              <a:t xml:space="preserve">Your Eval Suite Has a Grandfather</a:t>
+              <a:t xml:space="preserve">Three Search Methods in a Fundable</a:t>
+            </a:r>
+            <a:endParaRPr lang="en-US" sz="3750"/>
+          </a:p>
+          <a:p>
+            <a:pPr marL="0" indent="0">
+              <a:lnSpc>
+                <a:spcPts val="4500"/>
+              </a:lnSpc>
+              <a:spcAft>
+                <a:spcPts val="0"/>
+              </a:spcAft>
+              <a:buNone/>
+            </a:pPr>
+            <a:r>
+              <a:rPr lang="en-US" sz="3750" b="1">
+                <a:solidFill>
+                  <a:srgbClr val="202B33"/>
+                </a:solidFill>
+                <a:latin typeface="Arial"/>
+                <a:ea typeface="Arial"/>
+                <a:cs typeface="Arial"/>
+              </a:rPr>
+              <a:t xml:space="preserve">Trenchcoat</a:t>
             </a:r>
             <a:endParaRPr lang="en-US" sz="3750"/>
           </a:p>
@@ -4834,7 +4857,7 @@
                 <a:ea typeface="Arial"/>
                 <a:cs typeface="Arial"/>
               </a:rPr>
-              <a:t xml:space="preserve">Your Eval Suite Has a Grandfather</a:t>
+              <a:t xml:space="preserve">Three Search Methods in a Fundable Trenchcoat</a:t>
             </a:r>
             <a:endParaRPr lang="en-US" sz="975"/>
           </a:p>
@@ -5667,7 +5690,7 @@
                 <a:ea typeface="Arial"/>
                 <a:cs typeface="Arial"/>
               </a:rPr>
-              <a:t xml:space="preserve">Your Eval Suite Has a Grandfather</a:t>
+              <a:t xml:space="preserve">Three Search Methods in a Fundable Trenchcoat</a:t>
             </a:r>
             <a:endParaRPr lang="en-US" sz="975"/>
           </a:p>
@@ -6500,7 +6523,7 @@
                 <a:ea typeface="Arial"/>
                 <a:cs typeface="Arial"/>
               </a:rPr>
-              <a:t xml:space="preserve">Your Eval Suite Has a Grandfather</a:t>
+              <a:t xml:space="preserve">Three Search Methods in a Fundable Trenchcoat</a:t>
             </a:r>
             <a:endParaRPr lang="en-US" sz="975"/>
           </a:p>
@@ -7287,7 +7310,7 @@
                 <a:ea typeface="Arial"/>
                 <a:cs typeface="Arial"/>
               </a:rPr>
-              <a:t xml:space="preserve">Your Eval Suite Has a Grandfather</a:t>
+              <a:t xml:space="preserve">Three Search Methods in a Fundable Trenchcoat</a:t>
             </a:r>
             <a:endParaRPr lang="en-US" sz="975"/>
           </a:p>
@@ -8281,7 +8304,7 @@
                 <a:ea typeface="Arial"/>
                 <a:cs typeface="Arial"/>
               </a:rPr>
-              <a:t xml:space="preserve">Your Eval Suite Has a Grandfather</a:t>
+              <a:t xml:space="preserve">Three Search Methods in a Fundable Trenchcoat</a:t>
             </a:r>
             <a:endParaRPr lang="en-US" sz="975"/>
           </a:p>
@@ -9077,7 +9100,7 @@
                 <a:ea typeface="Arial"/>
                 <a:cs typeface="Arial"/>
               </a:rPr>
-              <a:t xml:space="preserve">Your Eval Suite Has a Grandfather</a:t>
+              <a:t xml:space="preserve">Three Search Methods in a Fundable Trenchcoat</a:t>
             </a:r>
             <a:endParaRPr lang="en-US" sz="975"/>
           </a:p>
@@ -10186,7 +10209,7 @@
                 <a:ea typeface="Arial"/>
                 <a:cs typeface="Arial"/>
               </a:rPr>
-              <a:t xml:space="preserve">Your Eval Suite Has a Grandfather</a:t>
+              <a:t xml:space="preserve">Three Search Methods in a Fundable Trenchcoat</a:t>
             </a:r>
             <a:endParaRPr lang="en-US" sz="975"/>
           </a:p>
@@ -11088,7 +11111,7 @@
                 <a:ea typeface="Arial"/>
                 <a:cs typeface="Arial"/>
               </a:rPr>
-              <a:t xml:space="preserve">Your Eval Suite Has a Grandfather</a:t>
+              <a:t xml:space="preserve">Three Search Methods in a Fundable Trenchcoat</a:t>
             </a:r>
             <a:endParaRPr lang="en-US" sz="975"/>
           </a:p>
@@ -12013,7 +12036,7 @@
                 <a:ea typeface="Arial"/>
                 <a:cs typeface="Arial"/>
               </a:rPr>
-              <a:t xml:space="preserve">Your Eval Suite Has a Grandfather</a:t>
+              <a:t xml:space="preserve">Three Search Methods in a Fundable Trenchcoat</a:t>
             </a:r>
             <a:endParaRPr lang="en-US" sz="975"/>
           </a:p>
@@ -12242,7 +12265,30 @@
                 <a:ea typeface="Arial"/>
                 <a:cs typeface="Arial"/>
               </a:rPr>
-              <a:t xml:space="preserve">Your eval suite has a grandfather.</a:t>
+              <a:t xml:space="preserve">Three search methods in a fundable</a:t>
+            </a:r>
+            <a:endParaRPr lang="en-US" sz="1500"/>
+          </a:p>
+          <a:p>
+            <a:pPr marL="0" indent="0">
+              <a:lnSpc>
+                <a:spcPts val="1950"/>
+              </a:lnSpc>
+              <a:spcAft>
+                <a:spcPts val="0"/>
+              </a:spcAft>
+              <a:buNone/>
+            </a:pPr>
+            <a:r>
+              <a:rPr lang="en-US" sz="1500" b="0">
+                <a:solidFill>
+                  <a:srgbClr val="202B33"/>
+                </a:solidFill>
+                <a:latin typeface="Arial"/>
+                <a:ea typeface="Arial"/>
+                <a:cs typeface="Arial"/>
+              </a:rPr>
+              <a:t xml:space="preserve">trenchcoat.</a:t>
             </a:r>
             <a:endParaRPr lang="en-US" sz="1500"/>
           </a:p>
@@ -12450,29 +12496,6 @@
                 <a:cs typeface="Arial"/>
               </a:rPr>
               <a:t xml:space="preserve">Those words tell us why rare identifiers</a:t>
-            </a:r>
-            <a:endParaRPr lang="en-US" sz="1500"/>
-          </a:p>
-          <a:p>
-            <a:pPr marL="0" indent="0">
-              <a:lnSpc>
-                <a:spcPts val="1950"/>
-              </a:lnSpc>
-              <a:spcAft>
-                <a:spcPts val="0"/>
-              </a:spcAft>
-              <a:buNone/>
-            </a:pPr>
-            <a:r>
-              <a:rPr lang="en-US" sz="1500" b="0">
-                <a:solidFill>
-                  <a:srgbClr val="202B33"/>
-                </a:solidFill>
-                <a:latin typeface="Arial"/>
-                <a:ea typeface="Arial"/>
-                <a:cs typeface="Arial"/>
-              </a:rPr>
-              <a:t xml:space="preserve">matter, why synonyms are hard, why a</a:t>
             </a:r>
             <a:endParaRPr lang="en-US" sz="1500"/>
           </a:p>
@@ -12521,6 +12544,29 @@
                 <a:ea typeface="Arial"/>
                 <a:cs typeface="Arial"/>
               </a:rPr>
+              <a:t xml:space="preserve">matter, why synonyms are hard, why a</a:t>
+            </a:r>
+            <a:endParaRPr lang="en-US" sz="1500"/>
+          </a:p>
+          <a:p>
+            <a:pPr marL="0" indent="0">
+              <a:lnSpc>
+                <a:spcPts val="1950"/>
+              </a:lnSpc>
+              <a:spcAft>
+                <a:spcPts val="0"/>
+              </a:spcAft>
+              <a:buNone/>
+            </a:pPr>
+            <a:r>
+              <a:rPr lang="en-US" sz="1500" b="0">
+                <a:solidFill>
+                  <a:srgbClr val="202B33"/>
+                </a:solidFill>
+                <a:latin typeface="Arial"/>
+                <a:ea typeface="Arial"/>
+                <a:cs typeface="Arial"/>
+              </a:rPr>
               <a:t xml:space="preserve">passage needs its exception, and why the</a:t>
             </a:r>
             <a:endParaRPr lang="en-US" sz="1500"/>
@@ -12777,7 +12823,7 @@
                 <a:ea typeface="Arial"/>
                 <a:cs typeface="Arial"/>
               </a:rPr>
-              <a:t xml:space="preserve">Your Eval Suite Has a Grandfather</a:t>
+              <a:t xml:space="preserve">Three Search Methods in a Fundable Trenchcoat</a:t>
             </a:r>
             <a:endParaRPr lang="en-US" sz="975"/>
           </a:p>

</xml_diff>